<commit_message>
docs: align latest product proposal and interview deck
</commit_message>
<xml_diff>
--- a/output/huayi-world-tcm-ai-education-platform.pptx
+++ b/output/huayi-world-tcm-ai-education-platform.pptx
@@ -17,6 +17,8 @@
     <p:sldId id="265" r:id="rId16"/>
     <p:sldId id="266" r:id="rId17"/>
     <p:sldId id="267" r:id="rId18"/>
+    <p:sldId id="268" r:id="rId19"/>
+    <p:sldId id="269" r:id="rId20"/>
   </p:sldIdLst>
   <p:sldSz cx="12191695" cy="6858000" type="screen4x3"/>
   <p:notesSz cx="6858000" cy="9144000"/>
@@ -3219,7 +3221,7 @@
                 </a:solidFill>
                 <a:latin typeface="Microsoft YaHei"/>
               </a:rPr>
-              <a:t>面试方案 · 2026.10</a:t>
+              <a:t>面试方案 · 2026.10.29</a:t>
             </a:r>
           </a:p>
         </p:txBody>
@@ -5131,7 +5133,7 @@
                 </a:solidFill>
                 <a:latin typeface="Microsoft YaHei"/>
               </a:rPr>
-              <a:t>10 · 岗位边界</a:t>
+              <a:t>10 · 需求不足时</a:t>
             </a:r>
           </a:p>
         </p:txBody>
@@ -5205,7 +5207,7 @@
                 </a:solidFill>
                 <a:latin typeface="Microsoft YaHei"/>
               </a:rPr>
-              <a:t>我可以承担 0→1，但不会盲目承诺单人包办。</a:t>
+              <a:t>需求还不完整时，先把方向变成可验证的 MVP。</a:t>
             </a:r>
           </a:p>
         </p:txBody>
@@ -5244,7 +5246,7 @@
                 </a:solidFill>
                 <a:latin typeface="Microsoft YaHei"/>
               </a:rPr>
-              <a:t>先对结果负责，再把需要协作的边界讲清楚，反而更适合早期项目。</a:t>
+              <a:t>不假设全量课程、完整 App 和学习效果已经定义，先补齐最小决策信息。</a:t>
             </a:r>
           </a:p>
         </p:txBody>
@@ -5257,15 +5259,660 @@
         </p:nvSpPr>
         <p:spPr>
           <a:xfrm>
-            <a:off x="749808" y="2743200"/>
-            <a:ext cx="5166360" cy="2423160"/>
+            <a:off x="777240" y="2670048"/>
+            <a:ext cx="1143000" cy="502920"/>
           </a:xfrm>
           <a:prstGeom prst="roundRect">
             <a:avLst/>
           </a:prstGeom>
           <a:solidFill>
-            <a:srgbClr val="1E5A4A"/>
+            <a:srgbClr val="C85D48"/>
           </a:solidFill>
+          <a:ln w="10160">
+            <a:solidFill>
+              <a:srgbClr val="C85D48"/>
+            </a:solidFill>
+          </a:ln>
+        </p:spPr>
+        <p:style>
+          <a:lnRef idx="1">
+            <a:schemeClr val="accent1"/>
+          </a:lnRef>
+          <a:fillRef idx="3">
+            <a:schemeClr val="accent1"/>
+          </a:fillRef>
+          <a:effectRef idx="2">
+            <a:schemeClr val="accent1"/>
+          </a:effectRef>
+          <a:fontRef idx="minor">
+            <a:schemeClr val="lt1"/>
+          </a:fontRef>
+        </p:style>
+        <p:txBody>
+          <a:bodyPr rtlCol="0" anchor="ctr"/>
+          <a:lstStyle/>
+          <a:p>
+            <a:pPr algn="ctr"/>
+          </a:p>
+        </p:txBody>
+      </p:sp>
+      <p:sp>
+        <p:nvSpPr>
+          <p:cNvPr id="9" name="TextBox 8"/>
+          <p:cNvSpPr txBox="1"/>
+          <p:nvPr/>
+        </p:nvSpPr>
+        <p:spPr>
+          <a:xfrm>
+            <a:off x="914400" y="2825496"/>
+            <a:ext cx="868680" cy="182880"/>
+          </a:xfrm>
+          <a:prstGeom prst="rect">
+            <a:avLst/>
+          </a:prstGeom>
+          <a:noFill/>
+        </p:spPr>
+        <p:txBody>
+          <a:bodyPr wrap="square" lIns="0" rIns="0" tIns="0" bIns="0" anchor="t">
+            <a:spAutoFit/>
+          </a:bodyPr>
+          <a:lstStyle/>
+          <a:p>
+            <a:pPr algn="ctr">
+              <a:spcAft>
+                <a:spcPts val="0"/>
+              </a:spcAft>
+            </a:pPr>
+            <a:r>
+              <a:rPr sz="1200" b="1" i="0">
+                <a:solidFill>
+                  <a:srgbClr val="FFFDF8"/>
+                </a:solidFill>
+                <a:latin typeface="Microsoft YaHei"/>
+              </a:rPr>
+              <a:t>用户</a:t>
+            </a:r>
+          </a:p>
+        </p:txBody>
+      </p:sp>
+      <p:sp>
+        <p:nvSpPr>
+          <p:cNvPr id="10" name="TextBox 9"/>
+          <p:cNvSpPr txBox="1"/>
+          <p:nvPr/>
+        </p:nvSpPr>
+        <p:spPr>
+          <a:xfrm>
+            <a:off x="2212848" y="2724912"/>
+            <a:ext cx="1828800" cy="219456"/>
+          </a:xfrm>
+          <a:prstGeom prst="rect">
+            <a:avLst/>
+          </a:prstGeom>
+          <a:noFill/>
+        </p:spPr>
+        <p:txBody>
+          <a:bodyPr wrap="square" lIns="0" rIns="0" tIns="0" bIns="0" anchor="t">
+            <a:spAutoFit/>
+          </a:bodyPr>
+          <a:lstStyle/>
+          <a:p>
+            <a:pPr algn="l">
+              <a:spcAft>
+                <a:spcPts val="0"/>
+              </a:spcAft>
+            </a:pPr>
+            <a:r>
+              <a:rPr sz="1300" b="1" i="0">
+                <a:solidFill>
+                  <a:srgbClr val="D7C58F"/>
+                </a:solidFill>
+                <a:latin typeface="Microsoft YaHei"/>
+              </a:rPr>
+              <a:t>先服务谁？</a:t>
+            </a:r>
+          </a:p>
+        </p:txBody>
+      </p:sp>
+      <p:sp>
+        <p:nvSpPr>
+          <p:cNvPr id="11" name="TextBox 10"/>
+          <p:cNvSpPr txBox="1"/>
+          <p:nvPr/>
+        </p:nvSpPr>
+        <p:spPr>
+          <a:xfrm>
+            <a:off x="4160520" y="2724912"/>
+            <a:ext cx="6583680" cy="292608"/>
+          </a:xfrm>
+          <a:prstGeom prst="rect">
+            <a:avLst/>
+          </a:prstGeom>
+          <a:noFill/>
+        </p:spPr>
+        <p:txBody>
+          <a:bodyPr wrap="square" lIns="0" rIns="0" tIns="0" bIns="0" anchor="t">
+            <a:spAutoFit/>
+          </a:bodyPr>
+          <a:lstStyle/>
+          <a:p>
+            <a:pPr algn="l">
+              <a:spcAft>
+                <a:spcPts val="0"/>
+              </a:spcAft>
+            </a:pPr>
+            <a:r>
+              <a:rPr sz="1100" b="0" i="0">
+                <a:solidFill>
+                  <a:srgbClr val="C7D6CC"/>
+                </a:solidFill>
+                <a:latin typeface="Microsoft YaHei"/>
+              </a:rPr>
+              <a:t>访谈学员、老师和班主任，按频次与耗时选场景</a:t>
+            </a:r>
+          </a:p>
+        </p:txBody>
+      </p:sp>
+      <p:sp>
+        <p:nvSpPr>
+          <p:cNvPr id="12" name="Rounded Rectangle 11"/>
+          <p:cNvSpPr/>
+          <p:nvPr/>
+        </p:nvSpPr>
+        <p:spPr>
+          <a:xfrm>
+            <a:off x="777240" y="3374136"/>
+            <a:ext cx="1143000" cy="502920"/>
+          </a:xfrm>
+          <a:prstGeom prst="roundRect">
+            <a:avLst/>
+          </a:prstGeom>
+          <a:solidFill>
+            <a:srgbClr val="C85D48"/>
+          </a:solidFill>
+          <a:ln w="10160">
+            <a:solidFill>
+              <a:srgbClr val="C85D48"/>
+            </a:solidFill>
+          </a:ln>
+        </p:spPr>
+        <p:style>
+          <a:lnRef idx="1">
+            <a:schemeClr val="accent1"/>
+          </a:lnRef>
+          <a:fillRef idx="3">
+            <a:schemeClr val="accent1"/>
+          </a:fillRef>
+          <a:effectRef idx="2">
+            <a:schemeClr val="accent1"/>
+          </a:effectRef>
+          <a:fontRef idx="minor">
+            <a:schemeClr val="lt1"/>
+          </a:fontRef>
+        </p:style>
+        <p:txBody>
+          <a:bodyPr rtlCol="0" anchor="ctr"/>
+          <a:lstStyle/>
+          <a:p>
+            <a:pPr algn="ctr"/>
+          </a:p>
+        </p:txBody>
+      </p:sp>
+      <p:sp>
+        <p:nvSpPr>
+          <p:cNvPr id="13" name="TextBox 12"/>
+          <p:cNvSpPr txBox="1"/>
+          <p:nvPr/>
+        </p:nvSpPr>
+        <p:spPr>
+          <a:xfrm>
+            <a:off x="914400" y="3529584"/>
+            <a:ext cx="868680" cy="182880"/>
+          </a:xfrm>
+          <a:prstGeom prst="rect">
+            <a:avLst/>
+          </a:prstGeom>
+          <a:noFill/>
+        </p:spPr>
+        <p:txBody>
+          <a:bodyPr wrap="square" lIns="0" rIns="0" tIns="0" bIns="0" anchor="t">
+            <a:spAutoFit/>
+          </a:bodyPr>
+          <a:lstStyle/>
+          <a:p>
+            <a:pPr algn="ctr">
+              <a:spcAft>
+                <a:spcPts val="0"/>
+              </a:spcAft>
+            </a:pPr>
+            <a:r>
+              <a:rPr sz="1200" b="1" i="0">
+                <a:solidFill>
+                  <a:srgbClr val="FFFDF8"/>
+                </a:solidFill>
+                <a:latin typeface="Microsoft YaHei"/>
+              </a:rPr>
+              <a:t>内容</a:t>
+            </a:r>
+          </a:p>
+        </p:txBody>
+      </p:sp>
+      <p:sp>
+        <p:nvSpPr>
+          <p:cNvPr id="14" name="TextBox 13"/>
+          <p:cNvSpPr txBox="1"/>
+          <p:nvPr/>
+        </p:nvSpPr>
+        <p:spPr>
+          <a:xfrm>
+            <a:off x="2212848" y="3429000"/>
+            <a:ext cx="1828800" cy="219456"/>
+          </a:xfrm>
+          <a:prstGeom prst="rect">
+            <a:avLst/>
+          </a:prstGeom>
+          <a:noFill/>
+        </p:spPr>
+        <p:txBody>
+          <a:bodyPr wrap="square" lIns="0" rIns="0" tIns="0" bIns="0" anchor="t">
+            <a:spAutoFit/>
+          </a:bodyPr>
+          <a:lstStyle/>
+          <a:p>
+            <a:pPr algn="l">
+              <a:spcAft>
+                <a:spcPts val="0"/>
+              </a:spcAft>
+            </a:pPr>
+            <a:r>
+              <a:rPr sz="1300" b="1" i="0">
+                <a:solidFill>
+                  <a:srgbClr val="D7C58F"/>
+                </a:solidFill>
+                <a:latin typeface="Microsoft YaHei"/>
+              </a:rPr>
+              <a:t>哪些资料能用？</a:t>
+            </a:r>
+          </a:p>
+        </p:txBody>
+      </p:sp>
+      <p:sp>
+        <p:nvSpPr>
+          <p:cNvPr id="15" name="TextBox 14"/>
+          <p:cNvSpPr txBox="1"/>
+          <p:nvPr/>
+        </p:nvSpPr>
+        <p:spPr>
+          <a:xfrm>
+            <a:off x="4160520" y="3429000"/>
+            <a:ext cx="6583680" cy="292608"/>
+          </a:xfrm>
+          <a:prstGeom prst="rect">
+            <a:avLst/>
+          </a:prstGeom>
+          <a:noFill/>
+        </p:spPr>
+        <p:txBody>
+          <a:bodyPr wrap="square" lIns="0" rIns="0" tIns="0" bIns="0" anchor="t">
+            <a:spAutoFit/>
+          </a:bodyPr>
+          <a:lstStyle/>
+          <a:p>
+            <a:pPr algn="l">
+              <a:spcAft>
+                <a:spcPts val="0"/>
+              </a:spcAft>
+            </a:pPr>
+            <a:r>
+              <a:rPr sz="1100" b="0" i="0">
+                <a:solidFill>
+                  <a:srgbClr val="C7D6CC"/>
+                </a:solidFill>
+                <a:latin typeface="Microsoft YaHei"/>
+              </a:rPr>
+              <a:t>先用一门授权课程和合成医案建立边界</a:t>
+            </a:r>
+          </a:p>
+        </p:txBody>
+      </p:sp>
+      <p:sp>
+        <p:nvSpPr>
+          <p:cNvPr id="16" name="Rounded Rectangle 15"/>
+          <p:cNvSpPr/>
+          <p:nvPr/>
+        </p:nvSpPr>
+        <p:spPr>
+          <a:xfrm>
+            <a:off x="777240" y="4078224"/>
+            <a:ext cx="1143000" cy="502920"/>
+          </a:xfrm>
+          <a:prstGeom prst="roundRect">
+            <a:avLst/>
+          </a:prstGeom>
+          <a:solidFill>
+            <a:srgbClr val="C85D48"/>
+          </a:solidFill>
+          <a:ln w="10160">
+            <a:solidFill>
+              <a:srgbClr val="C85D48"/>
+            </a:solidFill>
+          </a:ln>
+        </p:spPr>
+        <p:style>
+          <a:lnRef idx="1">
+            <a:schemeClr val="accent1"/>
+          </a:lnRef>
+          <a:fillRef idx="3">
+            <a:schemeClr val="accent1"/>
+          </a:fillRef>
+          <a:effectRef idx="2">
+            <a:schemeClr val="accent1"/>
+          </a:effectRef>
+          <a:fontRef idx="minor">
+            <a:schemeClr val="lt1"/>
+          </a:fontRef>
+        </p:style>
+        <p:txBody>
+          <a:bodyPr rtlCol="0" anchor="ctr"/>
+          <a:lstStyle/>
+          <a:p>
+            <a:pPr algn="ctr"/>
+          </a:p>
+        </p:txBody>
+      </p:sp>
+      <p:sp>
+        <p:nvSpPr>
+          <p:cNvPr id="17" name="TextBox 16"/>
+          <p:cNvSpPr txBox="1"/>
+          <p:nvPr/>
+        </p:nvSpPr>
+        <p:spPr>
+          <a:xfrm>
+            <a:off x="914400" y="4233672"/>
+            <a:ext cx="868680" cy="182880"/>
+          </a:xfrm>
+          <a:prstGeom prst="rect">
+            <a:avLst/>
+          </a:prstGeom>
+          <a:noFill/>
+        </p:spPr>
+        <p:txBody>
+          <a:bodyPr wrap="square" lIns="0" rIns="0" tIns="0" bIns="0" anchor="t">
+            <a:spAutoFit/>
+          </a:bodyPr>
+          <a:lstStyle/>
+          <a:p>
+            <a:pPr algn="ctr">
+              <a:spcAft>
+                <a:spcPts val="0"/>
+              </a:spcAft>
+            </a:pPr>
+            <a:r>
+              <a:rPr sz="1200" b="1" i="0">
+                <a:solidFill>
+                  <a:srgbClr val="FFFDF8"/>
+                </a:solidFill>
+                <a:latin typeface="Microsoft YaHei"/>
+              </a:rPr>
+              <a:t>指标</a:t>
+            </a:r>
+          </a:p>
+        </p:txBody>
+      </p:sp>
+      <p:sp>
+        <p:nvSpPr>
+          <p:cNvPr id="18" name="TextBox 17"/>
+          <p:cNvSpPr txBox="1"/>
+          <p:nvPr/>
+        </p:nvSpPr>
+        <p:spPr>
+          <a:xfrm>
+            <a:off x="2212848" y="4133087"/>
+            <a:ext cx="1828800" cy="219456"/>
+          </a:xfrm>
+          <a:prstGeom prst="rect">
+            <a:avLst/>
+          </a:prstGeom>
+          <a:noFill/>
+        </p:spPr>
+        <p:txBody>
+          <a:bodyPr wrap="square" lIns="0" rIns="0" tIns="0" bIns="0" anchor="t">
+            <a:spAutoFit/>
+          </a:bodyPr>
+          <a:lstStyle/>
+          <a:p>
+            <a:pPr algn="l">
+              <a:spcAft>
+                <a:spcPts val="0"/>
+              </a:spcAft>
+            </a:pPr>
+            <a:r>
+              <a:rPr sz="1300" b="1" i="0">
+                <a:solidFill>
+                  <a:srgbClr val="D7C58F"/>
+                </a:solidFill>
+                <a:latin typeface="Microsoft YaHei"/>
+              </a:rPr>
+              <a:t>什么叫有效？</a:t>
+            </a:r>
+          </a:p>
+        </p:txBody>
+      </p:sp>
+      <p:sp>
+        <p:nvSpPr>
+          <p:cNvPr id="19" name="TextBox 18"/>
+          <p:cNvSpPr txBox="1"/>
+          <p:nvPr/>
+        </p:nvSpPr>
+        <p:spPr>
+          <a:xfrm>
+            <a:off x="4160520" y="4133087"/>
+            <a:ext cx="6583680" cy="292608"/>
+          </a:xfrm>
+          <a:prstGeom prst="rect">
+            <a:avLst/>
+          </a:prstGeom>
+          <a:noFill/>
+        </p:spPr>
+        <p:txBody>
+          <a:bodyPr wrap="square" lIns="0" rIns="0" tIns="0" bIns="0" anchor="t">
+            <a:spAutoFit/>
+          </a:bodyPr>
+          <a:lstStyle/>
+          <a:p>
+            <a:pPr algn="l">
+              <a:spcAft>
+                <a:spcPts val="0"/>
+              </a:spcAft>
+            </a:pPr>
+            <a:r>
+              <a:rPr sz="1100" b="0" i="0">
+                <a:solidFill>
+                  <a:srgbClr val="C7D6CC"/>
+                </a:solidFill>
+                <a:latin typeface="Microsoft YaHei"/>
+              </a:rPr>
+              <a:t>先记录答疑时间、练习完成、教师采纳等基线</a:t>
+            </a:r>
+          </a:p>
+        </p:txBody>
+      </p:sp>
+      <p:sp>
+        <p:nvSpPr>
+          <p:cNvPr id="20" name="Rounded Rectangle 19"/>
+          <p:cNvSpPr/>
+          <p:nvPr/>
+        </p:nvSpPr>
+        <p:spPr>
+          <a:xfrm>
+            <a:off x="777240" y="4782312"/>
+            <a:ext cx="1143000" cy="502920"/>
+          </a:xfrm>
+          <a:prstGeom prst="roundRect">
+            <a:avLst/>
+          </a:prstGeom>
+          <a:solidFill>
+            <a:srgbClr val="C85D48"/>
+          </a:solidFill>
+          <a:ln w="10160">
+            <a:solidFill>
+              <a:srgbClr val="C85D48"/>
+            </a:solidFill>
+          </a:ln>
+        </p:spPr>
+        <p:style>
+          <a:lnRef idx="1">
+            <a:schemeClr val="accent1"/>
+          </a:lnRef>
+          <a:fillRef idx="3">
+            <a:schemeClr val="accent1"/>
+          </a:fillRef>
+          <a:effectRef idx="2">
+            <a:schemeClr val="accent1"/>
+          </a:effectRef>
+          <a:fontRef idx="minor">
+            <a:schemeClr val="lt1"/>
+          </a:fontRef>
+        </p:style>
+        <p:txBody>
+          <a:bodyPr rtlCol="0" anchor="ctr"/>
+          <a:lstStyle/>
+          <a:p>
+            <a:pPr algn="ctr"/>
+          </a:p>
+        </p:txBody>
+      </p:sp>
+      <p:sp>
+        <p:nvSpPr>
+          <p:cNvPr id="21" name="TextBox 20"/>
+          <p:cNvSpPr txBox="1"/>
+          <p:nvPr/>
+        </p:nvSpPr>
+        <p:spPr>
+          <a:xfrm>
+            <a:off x="914400" y="4937760"/>
+            <a:ext cx="868680" cy="182880"/>
+          </a:xfrm>
+          <a:prstGeom prst="rect">
+            <a:avLst/>
+          </a:prstGeom>
+          <a:noFill/>
+        </p:spPr>
+        <p:txBody>
+          <a:bodyPr wrap="square" lIns="0" rIns="0" tIns="0" bIns="0" anchor="t">
+            <a:spAutoFit/>
+          </a:bodyPr>
+          <a:lstStyle/>
+          <a:p>
+            <a:pPr algn="ctr">
+              <a:spcAft>
+                <a:spcPts val="0"/>
+              </a:spcAft>
+            </a:pPr>
+            <a:r>
+              <a:rPr sz="1200" b="1" i="0">
+                <a:solidFill>
+                  <a:srgbClr val="FFFDF8"/>
+                </a:solidFill>
+                <a:latin typeface="Microsoft YaHei"/>
+              </a:rPr>
+              <a:t>渠道</a:t>
+            </a:r>
+          </a:p>
+        </p:txBody>
+      </p:sp>
+      <p:sp>
+        <p:nvSpPr>
+          <p:cNvPr id="22" name="TextBox 21"/>
+          <p:cNvSpPr txBox="1"/>
+          <p:nvPr/>
+        </p:nvSpPr>
+        <p:spPr>
+          <a:xfrm>
+            <a:off x="2212848" y="4837176"/>
+            <a:ext cx="1828800" cy="219456"/>
+          </a:xfrm>
+          <a:prstGeom prst="rect">
+            <a:avLst/>
+          </a:prstGeom>
+          <a:noFill/>
+        </p:spPr>
+        <p:txBody>
+          <a:bodyPr wrap="square" lIns="0" rIns="0" tIns="0" bIns="0" anchor="t">
+            <a:spAutoFit/>
+          </a:bodyPr>
+          <a:lstStyle/>
+          <a:p>
+            <a:pPr algn="l">
+              <a:spcAft>
+                <a:spcPts val="0"/>
+              </a:spcAft>
+            </a:pPr>
+            <a:r>
+              <a:rPr sz="1300" b="1" i="0">
+                <a:solidFill>
+                  <a:srgbClr val="D7C58F"/>
+                </a:solidFill>
+                <a:latin typeface="Microsoft YaHei"/>
+              </a:rPr>
+              <a:t>是否马上做 App？</a:t>
+            </a:r>
+          </a:p>
+        </p:txBody>
+      </p:sp>
+      <p:sp>
+        <p:nvSpPr>
+          <p:cNvPr id="23" name="TextBox 22"/>
+          <p:cNvSpPr txBox="1"/>
+          <p:nvPr/>
+        </p:nvSpPr>
+        <p:spPr>
+          <a:xfrm>
+            <a:off x="4160520" y="4837176"/>
+            <a:ext cx="6583680" cy="292608"/>
+          </a:xfrm>
+          <a:prstGeom prst="rect">
+            <a:avLst/>
+          </a:prstGeom>
+          <a:noFill/>
+        </p:spPr>
+        <p:txBody>
+          <a:bodyPr wrap="square" lIns="0" rIns="0" tIns="0" bIns="0" anchor="t">
+            <a:spAutoFit/>
+          </a:bodyPr>
+          <a:lstStyle/>
+          <a:p>
+            <a:pPr algn="l">
+              <a:spcAft>
+                <a:spcPts val="0"/>
+              </a:spcAft>
+            </a:pPr>
+            <a:r>
+              <a:rPr sz="1100" b="0" i="0">
+                <a:solidFill>
+                  <a:srgbClr val="C7D6CC"/>
+                </a:solidFill>
+                <a:latin typeface="Microsoft YaHei"/>
+              </a:rPr>
+              <a:t>先用 Web/H5 + API 验证闭环，再排接入优先级</a:t>
+            </a:r>
+          </a:p>
+        </p:txBody>
+      </p:sp>
+      <p:cxnSp>
+        <p:nvCxnSpPr>
+          <p:cNvPr id="24" name="Connector 23"/>
+          <p:cNvCxnSpPr/>
+          <p:nvPr/>
+        </p:nvCxnSpPr>
+        <p:spPr>
+          <a:xfrm>
+            <a:off x="777240" y="5623560"/>
+            <a:ext cx="10607040" cy="0"/>
+          </a:xfrm>
+          <a:prstGeom prst="line">
+            <a:avLst/>
+          </a:prstGeom>
           <a:ln w="10160">
             <a:solidFill>
               <a:srgbClr val="477A69"/>
@@ -5273,269 +5920,55 @@
           </a:ln>
         </p:spPr>
         <p:style>
-          <a:lnRef idx="1">
+          <a:lnRef idx="2">
             <a:schemeClr val="accent1"/>
           </a:lnRef>
-          <a:fillRef idx="3">
+          <a:fillRef idx="0">
             <a:schemeClr val="accent1"/>
           </a:fillRef>
-          <a:effectRef idx="2">
+          <a:effectRef idx="1">
             <a:schemeClr val="accent1"/>
           </a:effectRef>
           <a:fontRef idx="minor">
-            <a:schemeClr val="lt1"/>
+            <a:schemeClr val="tx1"/>
           </a:fontRef>
         </p:style>
-        <p:txBody>
-          <a:bodyPr rtlCol="0" anchor="ctr"/>
-          <a:lstStyle/>
-          <a:p>
-            <a:pPr algn="ctr"/>
-          </a:p>
-        </p:txBody>
-      </p:sp>
-      <p:sp>
-        <p:nvSpPr>
-          <p:cNvPr id="9" name="TextBox 8"/>
-          <p:cNvSpPr txBox="1"/>
-          <p:nvPr/>
-        </p:nvSpPr>
-        <p:spPr>
-          <a:xfrm>
-            <a:off x="1024128" y="3063240"/>
-            <a:ext cx="2377440" cy="274320"/>
-          </a:xfrm>
-          <a:prstGeom prst="rect">
-            <a:avLst/>
-          </a:prstGeom>
-          <a:noFill/>
-        </p:spPr>
-        <p:txBody>
-          <a:bodyPr wrap="square" lIns="0" rIns="0" tIns="0" bIns="0" anchor="t">
-            <a:spAutoFit/>
-          </a:bodyPr>
-          <a:lstStyle/>
-          <a:p>
-            <a:pPr algn="l">
-              <a:spcAft>
-                <a:spcPts val="0"/>
-              </a:spcAft>
-            </a:pPr>
-            <a:r>
-              <a:rPr sz="1800" b="1" i="0">
+      </p:cxnSp>
+      <p:sp>
+        <p:nvSpPr>
+          <p:cNvPr id="25" name="TextBox 24"/>
+          <p:cNvSpPr txBox="1"/>
+          <p:nvPr/>
+        </p:nvSpPr>
+        <p:spPr>
+          <a:xfrm>
+            <a:off x="786384" y="5760720"/>
+            <a:ext cx="10607040" cy="228600"/>
+          </a:xfrm>
+          <a:prstGeom prst="rect">
+            <a:avLst/>
+          </a:prstGeom>
+          <a:noFill/>
+        </p:spPr>
+        <p:txBody>
+          <a:bodyPr wrap="square" lIns="0" rIns="0" tIns="0" bIns="0" anchor="t">
+            <a:spAutoFit/>
+          </a:bodyPr>
+          <a:lstStyle/>
+          <a:p>
+            <a:pPr algn="l">
+              <a:spcAft>
+                <a:spcPts val="0"/>
+              </a:spcAft>
+            </a:pPr>
+            <a:r>
+              <a:rPr sz="1200" b="1" i="0">
                 <a:solidFill>
                   <a:srgbClr val="D7C58F"/>
                 </a:solidFill>
                 <a:latin typeface="Microsoft YaHei"/>
               </a:rPr>
-              <a:t>我可以独立负责</a:t>
-            </a:r>
-          </a:p>
-        </p:txBody>
-      </p:sp>
-      <p:sp>
-        <p:nvSpPr>
-          <p:cNvPr id="10" name="TextBox 9"/>
-          <p:cNvSpPr txBox="1"/>
-          <p:nvPr/>
-        </p:nvSpPr>
-        <p:spPr>
-          <a:xfrm>
-            <a:off x="1024128" y="3584448"/>
-            <a:ext cx="4297680" cy="1143000"/>
-          </a:xfrm>
-          <a:prstGeom prst="rect">
-            <a:avLst/>
-          </a:prstGeom>
-          <a:noFill/>
-        </p:spPr>
-        <p:txBody>
-          <a:bodyPr wrap="square" lIns="0" rIns="0" tIns="0" bIns="0" anchor="t">
-            <a:spAutoFit/>
-          </a:bodyPr>
-          <a:lstStyle/>
-          <a:p>
-            <a:pPr algn="l">
-              <a:spcAft>
-                <a:spcPts val="0"/>
-              </a:spcAft>
-            </a:pPr>
-            <a:r>
-              <a:rPr sz="1200" b="0" i="0">
-                <a:solidFill>
-                  <a:srgbClr val="FFFDF8"/>
-                </a:solidFill>
-                <a:latin typeface="Microsoft YaHei"/>
-              </a:rPr>
-              <a:t>场景调研与 MVP 定义
-AI 应用层：RAG、Agent、提示词、接口
-前端原型、流式体验、部署与 Trace
-评测集、Bad Case 和迭代文档</a:t>
-            </a:r>
-          </a:p>
-        </p:txBody>
-      </p:sp>
-      <p:sp>
-        <p:nvSpPr>
-          <p:cNvPr id="11" name="Rounded Rectangle 10"/>
-          <p:cNvSpPr/>
-          <p:nvPr/>
-        </p:nvSpPr>
-        <p:spPr>
-          <a:xfrm>
-            <a:off x="6245352" y="2743200"/>
-            <a:ext cx="5166360" cy="2423160"/>
-          </a:xfrm>
-          <a:prstGeom prst="roundRect">
-            <a:avLst/>
-          </a:prstGeom>
-          <a:solidFill>
-            <a:srgbClr val="174A40"/>
-          </a:solidFill>
-          <a:ln w="10160">
-            <a:solidFill>
-              <a:srgbClr val="477A69"/>
-            </a:solidFill>
-          </a:ln>
-        </p:spPr>
-        <p:style>
-          <a:lnRef idx="1">
-            <a:schemeClr val="accent1"/>
-          </a:lnRef>
-          <a:fillRef idx="3">
-            <a:schemeClr val="accent1"/>
-          </a:fillRef>
-          <a:effectRef idx="2">
-            <a:schemeClr val="accent1"/>
-          </a:effectRef>
-          <a:fontRef idx="minor">
-            <a:schemeClr val="lt1"/>
-          </a:fontRef>
-        </p:style>
-        <p:txBody>
-          <a:bodyPr rtlCol="0" anchor="ctr"/>
-          <a:lstStyle/>
-          <a:p>
-            <a:pPr algn="ctr"/>
-          </a:p>
-        </p:txBody>
-      </p:sp>
-      <p:sp>
-        <p:nvSpPr>
-          <p:cNvPr id="12" name="TextBox 11"/>
-          <p:cNvSpPr txBox="1"/>
-          <p:nvPr/>
-        </p:nvSpPr>
-        <p:spPr>
-          <a:xfrm>
-            <a:off x="6519672" y="3063240"/>
-            <a:ext cx="2560320" cy="274320"/>
-          </a:xfrm>
-          <a:prstGeom prst="rect">
-            <a:avLst/>
-          </a:prstGeom>
-          <a:noFill/>
-        </p:spPr>
-        <p:txBody>
-          <a:bodyPr wrap="square" lIns="0" rIns="0" tIns="0" bIns="0" anchor="t">
-            <a:spAutoFit/>
-          </a:bodyPr>
-          <a:lstStyle/>
-          <a:p>
-            <a:pPr algn="l">
-              <a:spcAft>
-                <a:spcPts val="0"/>
-              </a:spcAft>
-            </a:pPr>
-            <a:r>
-              <a:rPr sz="1800" b="1" i="0">
-                <a:solidFill>
-                  <a:srgbClr val="D7C58F"/>
-                </a:solidFill>
-                <a:latin typeface="Microsoft YaHei"/>
-              </a:rPr>
-              <a:t>正式上线需要协作</a:t>
-            </a:r>
-          </a:p>
-        </p:txBody>
-      </p:sp>
-      <p:sp>
-        <p:nvSpPr>
-          <p:cNvPr id="13" name="TextBox 12"/>
-          <p:cNvSpPr txBox="1"/>
-          <p:nvPr/>
-        </p:nvSpPr>
-        <p:spPr>
-          <a:xfrm>
-            <a:off x="6519672" y="3584448"/>
-            <a:ext cx="4297680" cy="1143000"/>
-          </a:xfrm>
-          <a:prstGeom prst="rect">
-            <a:avLst/>
-          </a:prstGeom>
-          <a:noFill/>
-        </p:spPr>
-        <p:txBody>
-          <a:bodyPr wrap="square" lIns="0" rIns="0" tIns="0" bIns="0" anchor="t">
-            <a:spAutoFit/>
-          </a:bodyPr>
-          <a:lstStyle/>
-          <a:p>
-            <a:pPr algn="l">
-              <a:spcAft>
-                <a:spcPts val="0"/>
-              </a:spcAft>
-            </a:pPr>
-            <a:r>
-              <a:rPr sz="1200" b="0" i="0">
-                <a:solidFill>
-                  <a:srgbClr val="C7D6CC"/>
-                </a:solidFill>
-                <a:latin typeface="Microsoft YaHei"/>
-              </a:rPr>
-              <a:t>App 正式接入与账号体系
-数据治理、运维、成本与安全
-中医教师审核与课程版权
-规模化并发和产品运营</a:t>
-            </a:r>
-          </a:p>
-        </p:txBody>
-      </p:sp>
-      <p:sp>
-        <p:nvSpPr>
-          <p:cNvPr id="14" name="TextBox 13"/>
-          <p:cNvSpPr txBox="1"/>
-          <p:nvPr/>
-        </p:nvSpPr>
-        <p:spPr>
-          <a:xfrm>
-            <a:off x="804672" y="5577840"/>
-            <a:ext cx="10469880" cy="274320"/>
-          </a:xfrm>
-          <a:prstGeom prst="rect">
-            <a:avLst/>
-          </a:prstGeom>
-          <a:noFill/>
-        </p:spPr>
-        <p:txBody>
-          <a:bodyPr wrap="square" lIns="0" rIns="0" tIns="0" bIns="0" anchor="t">
-            <a:spAutoFit/>
-          </a:bodyPr>
-          <a:lstStyle/>
-          <a:p>
-            <a:pPr algn="l">
-              <a:spcAft>
-                <a:spcPts val="0"/>
-              </a:spcAft>
-            </a:pPr>
-            <a:r>
-              <a:rPr sz="1200" b="1" i="0">
-                <a:solidFill>
-                  <a:srgbClr val="D7C58F"/>
-                </a:solidFill>
-                <a:latin typeface="Microsoft YaHei"/>
-              </a:rPr>
-              <a:t>岗位沟通：如果职责是 AI 方向从 0 到 1，我期望转正 25K 左右；具体可结合首期目标、资源和绩效机制沟通。</a:t>
+              <a:t>默认首期：一个课程主题 + 章节练习 + 一套医案 + 训练反馈 + 教师审核。两周内先验证是否值得扩展。</a:t>
             </a:r>
           </a:p>
         </p:txBody>
@@ -5678,7 +6111,1804 @@
                 </a:solidFill>
                 <a:latin typeface="Microsoft YaHei"/>
               </a:rPr>
-              <a:t>11 · 结论</a:t>
+              <a:t>11 · 边界与替代</a:t>
+            </a:r>
+          </a:p>
+        </p:txBody>
+      </p:sp>
+      <p:cxnSp>
+        <p:nvCxnSpPr>
+          <p:cNvPr id="5" name="Connector 4"/>
+          <p:cNvCxnSpPr/>
+          <p:nvPr/>
+        </p:nvCxnSpPr>
+        <p:spPr>
+          <a:xfrm>
+            <a:off x="502920" y="6245352"/>
+            <a:ext cx="11183112" cy="0"/>
+          </a:xfrm>
+          <a:prstGeom prst="line">
+            <a:avLst/>
+          </a:prstGeom>
+          <a:ln w="8890">
+            <a:solidFill>
+              <a:srgbClr val="D8D1C3"/>
+            </a:solidFill>
+          </a:ln>
+        </p:spPr>
+        <p:style>
+          <a:lnRef idx="2">
+            <a:schemeClr val="accent1"/>
+          </a:lnRef>
+          <a:fillRef idx="0">
+            <a:schemeClr val="accent1"/>
+          </a:fillRef>
+          <a:effectRef idx="1">
+            <a:schemeClr val="accent1"/>
+          </a:effectRef>
+          <a:fontRef idx="minor">
+            <a:schemeClr val="tx1"/>
+          </a:fontRef>
+        </p:style>
+      </p:cxnSp>
+      <p:sp>
+        <p:nvSpPr>
+          <p:cNvPr id="6" name="TextBox 5"/>
+          <p:cNvSpPr txBox="1"/>
+          <p:nvPr/>
+        </p:nvSpPr>
+        <p:spPr>
+          <a:xfrm>
+            <a:off x="685800" y="868680"/>
+            <a:ext cx="7498079" cy="960120"/>
+          </a:xfrm>
+          <a:prstGeom prst="rect">
+            <a:avLst/>
+          </a:prstGeom>
+          <a:noFill/>
+        </p:spPr>
+        <p:txBody>
+          <a:bodyPr wrap="square" lIns="0" rIns="0" tIns="0" bIns="0" anchor="t">
+            <a:spAutoFit/>
+          </a:bodyPr>
+          <a:lstStyle/>
+          <a:p>
+            <a:pPr algn="l">
+              <a:spcAft>
+                <a:spcPts val="0"/>
+              </a:spcAft>
+            </a:pPr>
+            <a:r>
+              <a:rPr sz="2800" b="1" i="0">
+                <a:solidFill>
+                  <a:srgbClr val="193630"/>
+                </a:solidFill>
+                <a:latin typeface="Microsoft YaHei"/>
+              </a:rPr>
+              <a:t>不能直接做的能力，也要给出解决路径。</a:t>
+            </a:r>
+          </a:p>
+        </p:txBody>
+      </p:sp>
+      <p:sp>
+        <p:nvSpPr>
+          <p:cNvPr id="7" name="TextBox 6"/>
+          <p:cNvSpPr txBox="1"/>
+          <p:nvPr/>
+        </p:nvSpPr>
+        <p:spPr>
+          <a:xfrm>
+            <a:off x="704088" y="1883664"/>
+            <a:ext cx="7955279" cy="548640"/>
+          </a:xfrm>
+          <a:prstGeom prst="rect">
+            <a:avLst/>
+          </a:prstGeom>
+          <a:noFill/>
+        </p:spPr>
+        <p:txBody>
+          <a:bodyPr wrap="square" lIns="0" rIns="0" tIns="0" bIns="0" anchor="t">
+            <a:spAutoFit/>
+          </a:bodyPr>
+          <a:lstStyle/>
+          <a:p>
+            <a:pPr algn="l">
+              <a:spcAft>
+                <a:spcPts val="0"/>
+              </a:spcAft>
+            </a:pPr>
+            <a:r>
+              <a:rPr sz="1200" b="0" i="0">
+                <a:solidFill>
+                  <a:srgbClr val="6D7B73"/>
+                </a:solidFill>
+                <a:latin typeface="Microsoft YaHei"/>
+              </a:rPr>
+              <a:t>把“当前缺口、Demo 替代、正式方案”分开说清楚，避免把概念当成已交付功能。</a:t>
+            </a:r>
+          </a:p>
+        </p:txBody>
+      </p:sp>
+      <p:sp>
+        <p:nvSpPr>
+          <p:cNvPr id="8" name="TextBox 7"/>
+          <p:cNvSpPr txBox="1"/>
+          <p:nvPr/>
+        </p:nvSpPr>
+        <p:spPr>
+          <a:xfrm>
+            <a:off x="749808" y="2487168"/>
+            <a:ext cx="2514600" cy="201168"/>
+          </a:xfrm>
+          <a:prstGeom prst="rect">
+            <a:avLst/>
+          </a:prstGeom>
+          <a:noFill/>
+        </p:spPr>
+        <p:txBody>
+          <a:bodyPr wrap="square" lIns="0" rIns="0" tIns="0" bIns="0" anchor="t">
+            <a:spAutoFit/>
+          </a:bodyPr>
+          <a:lstStyle/>
+          <a:p>
+            <a:pPr algn="l">
+              <a:spcAft>
+                <a:spcPts val="0"/>
+              </a:spcAft>
+            </a:pPr>
+            <a:r>
+              <a:rPr sz="1000" b="1" i="0">
+                <a:solidFill>
+                  <a:srgbClr val="C85D48"/>
+                </a:solidFill>
+                <a:latin typeface="Microsoft YaHei"/>
+              </a:rPr>
+              <a:t>当前不能直接做</a:t>
+            </a:r>
+          </a:p>
+        </p:txBody>
+      </p:sp>
+      <p:sp>
+        <p:nvSpPr>
+          <p:cNvPr id="9" name="TextBox 8"/>
+          <p:cNvSpPr txBox="1"/>
+          <p:nvPr/>
+        </p:nvSpPr>
+        <p:spPr>
+          <a:xfrm>
+            <a:off x="3337560" y="2487168"/>
+            <a:ext cx="2148840" cy="201168"/>
+          </a:xfrm>
+          <a:prstGeom prst="rect">
+            <a:avLst/>
+          </a:prstGeom>
+          <a:noFill/>
+        </p:spPr>
+        <p:txBody>
+          <a:bodyPr wrap="square" lIns="0" rIns="0" tIns="0" bIns="0" anchor="t">
+            <a:spAutoFit/>
+          </a:bodyPr>
+          <a:lstStyle/>
+          <a:p>
+            <a:pPr algn="l">
+              <a:spcAft>
+                <a:spcPts val="0"/>
+              </a:spcAft>
+            </a:pPr>
+            <a:r>
+              <a:rPr sz="1000" b="1" i="0">
+                <a:solidFill>
+                  <a:srgbClr val="C85D48"/>
+                </a:solidFill>
+                <a:latin typeface="Microsoft YaHei"/>
+              </a:rPr>
+              <a:t>原因</a:t>
+            </a:r>
+          </a:p>
+        </p:txBody>
+      </p:sp>
+      <p:sp>
+        <p:nvSpPr>
+          <p:cNvPr id="10" name="TextBox 9"/>
+          <p:cNvSpPr txBox="1"/>
+          <p:nvPr/>
+        </p:nvSpPr>
+        <p:spPr>
+          <a:xfrm>
+            <a:off x="5596128" y="2487168"/>
+            <a:ext cx="2331720" cy="201168"/>
+          </a:xfrm>
+          <a:prstGeom prst="rect">
+            <a:avLst/>
+          </a:prstGeom>
+          <a:noFill/>
+        </p:spPr>
+        <p:txBody>
+          <a:bodyPr wrap="square" lIns="0" rIns="0" tIns="0" bIns="0" anchor="t">
+            <a:spAutoFit/>
+          </a:bodyPr>
+          <a:lstStyle/>
+          <a:p>
+            <a:pPr algn="l">
+              <a:spcAft>
+                <a:spcPts val="0"/>
+              </a:spcAft>
+            </a:pPr>
+            <a:r>
+              <a:rPr sz="1000" b="1" i="0">
+                <a:solidFill>
+                  <a:srgbClr val="C85D48"/>
+                </a:solidFill>
+                <a:latin typeface="Microsoft YaHei"/>
+              </a:rPr>
+              <a:t>Demo 替代</a:t>
+            </a:r>
+          </a:p>
+        </p:txBody>
+      </p:sp>
+      <p:sp>
+        <p:nvSpPr>
+          <p:cNvPr id="11" name="TextBox 10"/>
+          <p:cNvSpPr txBox="1"/>
+          <p:nvPr/>
+        </p:nvSpPr>
+        <p:spPr>
+          <a:xfrm>
+            <a:off x="8065008" y="2487168"/>
+            <a:ext cx="3200400" cy="201168"/>
+          </a:xfrm>
+          <a:prstGeom prst="rect">
+            <a:avLst/>
+          </a:prstGeom>
+          <a:noFill/>
+        </p:spPr>
+        <p:txBody>
+          <a:bodyPr wrap="square" lIns="0" rIns="0" tIns="0" bIns="0" anchor="t">
+            <a:spAutoFit/>
+          </a:bodyPr>
+          <a:lstStyle/>
+          <a:p>
+            <a:pPr algn="l">
+              <a:spcAft>
+                <a:spcPts val="0"/>
+              </a:spcAft>
+            </a:pPr>
+            <a:r>
+              <a:rPr sz="1000" b="1" i="0">
+                <a:solidFill>
+                  <a:srgbClr val="C85D48"/>
+                </a:solidFill>
+                <a:latin typeface="Microsoft YaHei"/>
+              </a:rPr>
+              <a:t>正式方案</a:t>
+            </a:r>
+          </a:p>
+        </p:txBody>
+      </p:sp>
+      <p:cxnSp>
+        <p:nvCxnSpPr>
+          <p:cNvPr id="12" name="Connector 11"/>
+          <p:cNvCxnSpPr/>
+          <p:nvPr/>
+        </p:nvCxnSpPr>
+        <p:spPr>
+          <a:xfrm>
+            <a:off x="749808" y="2816352"/>
+            <a:ext cx="10634472" cy="0"/>
+          </a:xfrm>
+          <a:prstGeom prst="line">
+            <a:avLst/>
+          </a:prstGeom>
+          <a:ln w="10160">
+            <a:solidFill>
+              <a:srgbClr val="D8D1C3"/>
+            </a:solidFill>
+          </a:ln>
+        </p:spPr>
+        <p:style>
+          <a:lnRef idx="2">
+            <a:schemeClr val="accent1"/>
+          </a:lnRef>
+          <a:fillRef idx="0">
+            <a:schemeClr val="accent1"/>
+          </a:fillRef>
+          <a:effectRef idx="1">
+            <a:schemeClr val="accent1"/>
+          </a:effectRef>
+          <a:fontRef idx="minor">
+            <a:schemeClr val="tx1"/>
+          </a:fontRef>
+        </p:style>
+      </p:cxnSp>
+      <p:sp>
+        <p:nvSpPr>
+          <p:cNvPr id="13" name="TextBox 12"/>
+          <p:cNvSpPr txBox="1"/>
+          <p:nvPr/>
+        </p:nvSpPr>
+        <p:spPr>
+          <a:xfrm>
+            <a:off x="749808" y="2999232"/>
+            <a:ext cx="2514600" cy="347472"/>
+          </a:xfrm>
+          <a:prstGeom prst="rect">
+            <a:avLst/>
+          </a:prstGeom>
+          <a:noFill/>
+        </p:spPr>
+        <p:txBody>
+          <a:bodyPr wrap="square" lIns="0" rIns="0" tIns="0" bIns="0" anchor="t">
+            <a:spAutoFit/>
+          </a:bodyPr>
+          <a:lstStyle/>
+          <a:p>
+            <a:pPr algn="l">
+              <a:spcAft>
+                <a:spcPts val="0"/>
+              </a:spcAft>
+            </a:pPr>
+            <a:r>
+              <a:rPr sz="1000" b="1" i="0">
+                <a:solidFill>
+                  <a:srgbClr val="193630"/>
+                </a:solidFill>
+                <a:latin typeface="Microsoft YaHei"/>
+              </a:rPr>
+              <a:t>真实课程 AI 导师</a:t>
+            </a:r>
+          </a:p>
+        </p:txBody>
+      </p:sp>
+      <p:sp>
+        <p:nvSpPr>
+          <p:cNvPr id="14" name="TextBox 13"/>
+          <p:cNvSpPr txBox="1"/>
+          <p:nvPr/>
+        </p:nvSpPr>
+        <p:spPr>
+          <a:xfrm>
+            <a:off x="3337560" y="2999232"/>
+            <a:ext cx="2148840" cy="347472"/>
+          </a:xfrm>
+          <a:prstGeom prst="rect">
+            <a:avLst/>
+          </a:prstGeom>
+          <a:noFill/>
+        </p:spPr>
+        <p:txBody>
+          <a:bodyPr wrap="square" lIns="0" rIns="0" tIns="0" bIns="0" anchor="t">
+            <a:spAutoFit/>
+          </a:bodyPr>
+          <a:lstStyle/>
+          <a:p>
+            <a:pPr algn="l">
+              <a:spcAft>
+                <a:spcPts val="0"/>
+              </a:spcAft>
+            </a:pPr>
+            <a:r>
+              <a:rPr sz="1000" b="0" i="0">
+                <a:solidFill>
+                  <a:srgbClr val="193630"/>
+                </a:solidFill>
+                <a:latin typeface="Microsoft YaHei"/>
+              </a:rPr>
+              <a:t>缺课程原文/授权</a:t>
+            </a:r>
+          </a:p>
+        </p:txBody>
+      </p:sp>
+      <p:sp>
+        <p:nvSpPr>
+          <p:cNvPr id="15" name="TextBox 14"/>
+          <p:cNvSpPr txBox="1"/>
+          <p:nvPr/>
+        </p:nvSpPr>
+        <p:spPr>
+          <a:xfrm>
+            <a:off x="5596128" y="2999232"/>
+            <a:ext cx="2331720" cy="347472"/>
+          </a:xfrm>
+          <a:prstGeom prst="rect">
+            <a:avLst/>
+          </a:prstGeom>
+          <a:noFill/>
+        </p:spPr>
+        <p:txBody>
+          <a:bodyPr wrap="square" lIns="0" rIns="0" tIns="0" bIns="0" anchor="t">
+            <a:spAutoFit/>
+          </a:bodyPr>
+          <a:lstStyle/>
+          <a:p>
+            <a:pPr algn="l">
+              <a:spcAft>
+                <a:spcPts val="0"/>
+              </a:spcAft>
+            </a:pPr>
+            <a:r>
+              <a:rPr sz="1000" b="0" i="0">
+                <a:solidFill>
+                  <a:srgbClr val="193630"/>
+                </a:solidFill>
+                <a:latin typeface="Microsoft YaHei"/>
+              </a:rPr>
+              <a:t>固定演示资料</a:t>
+            </a:r>
+          </a:p>
+        </p:txBody>
+      </p:sp>
+      <p:sp>
+        <p:nvSpPr>
+          <p:cNvPr id="16" name="TextBox 15"/>
+          <p:cNvSpPr txBox="1"/>
+          <p:nvPr/>
+        </p:nvSpPr>
+        <p:spPr>
+          <a:xfrm>
+            <a:off x="8065008" y="2999232"/>
+            <a:ext cx="3200400" cy="347472"/>
+          </a:xfrm>
+          <a:prstGeom prst="rect">
+            <a:avLst/>
+          </a:prstGeom>
+          <a:noFill/>
+        </p:spPr>
+        <p:txBody>
+          <a:bodyPr wrap="square" lIns="0" rIns="0" tIns="0" bIns="0" anchor="t">
+            <a:spAutoFit/>
+          </a:bodyPr>
+          <a:lstStyle/>
+          <a:p>
+            <a:pPr algn="l">
+              <a:spcAft>
+                <a:spcPts val="0"/>
+              </a:spcAft>
+            </a:pPr>
+            <a:r>
+              <a:rPr sz="1000" b="0" i="0">
+                <a:solidFill>
+                  <a:srgbClr val="193630"/>
+                </a:solidFill>
+                <a:latin typeface="Microsoft YaHei"/>
+              </a:rPr>
+              <a:t>上传解析、知识单元审核</a:t>
+            </a:r>
+          </a:p>
+        </p:txBody>
+      </p:sp>
+      <p:cxnSp>
+        <p:nvCxnSpPr>
+          <p:cNvPr id="17" name="Connector 16"/>
+          <p:cNvCxnSpPr/>
+          <p:nvPr/>
+        </p:nvCxnSpPr>
+        <p:spPr>
+          <a:xfrm>
+            <a:off x="749808" y="3438144"/>
+            <a:ext cx="10634472" cy="0"/>
+          </a:xfrm>
+          <a:prstGeom prst="line">
+            <a:avLst/>
+          </a:prstGeom>
+          <a:ln w="6985">
+            <a:solidFill>
+              <a:srgbClr val="D8D1C3"/>
+            </a:solidFill>
+          </a:ln>
+        </p:spPr>
+        <p:style>
+          <a:lnRef idx="2">
+            <a:schemeClr val="accent1"/>
+          </a:lnRef>
+          <a:fillRef idx="0">
+            <a:schemeClr val="accent1"/>
+          </a:fillRef>
+          <a:effectRef idx="1">
+            <a:schemeClr val="accent1"/>
+          </a:effectRef>
+          <a:fontRef idx="minor">
+            <a:schemeClr val="tx1"/>
+          </a:fontRef>
+        </p:style>
+      </p:cxnSp>
+      <p:sp>
+        <p:nvSpPr>
+          <p:cNvPr id="18" name="TextBox 17"/>
+          <p:cNvSpPr txBox="1"/>
+          <p:nvPr/>
+        </p:nvSpPr>
+        <p:spPr>
+          <a:xfrm>
+            <a:off x="749808" y="3621024"/>
+            <a:ext cx="2514600" cy="347472"/>
+          </a:xfrm>
+          <a:prstGeom prst="rect">
+            <a:avLst/>
+          </a:prstGeom>
+          <a:noFill/>
+        </p:spPr>
+        <p:txBody>
+          <a:bodyPr wrap="square" lIns="0" rIns="0" tIns="0" bIns="0" anchor="t">
+            <a:spAutoFit/>
+          </a:bodyPr>
+          <a:lstStyle/>
+          <a:p>
+            <a:pPr algn="l">
+              <a:spcAft>
+                <a:spcPts val="0"/>
+              </a:spcAft>
+            </a:pPr>
+            <a:r>
+              <a:rPr sz="1000" b="1" i="0">
+                <a:solidFill>
+                  <a:srgbClr val="6D7B73"/>
+                </a:solidFill>
+                <a:latin typeface="Microsoft YaHei"/>
+              </a:rPr>
+              <a:t>长期能力画像</a:t>
+            </a:r>
+          </a:p>
+        </p:txBody>
+      </p:sp>
+      <p:sp>
+        <p:nvSpPr>
+          <p:cNvPr id="19" name="TextBox 18"/>
+          <p:cNvSpPr txBox="1"/>
+          <p:nvPr/>
+        </p:nvSpPr>
+        <p:spPr>
+          <a:xfrm>
+            <a:off x="3337560" y="3621024"/>
+            <a:ext cx="2148840" cy="347472"/>
+          </a:xfrm>
+          <a:prstGeom prst="rect">
+            <a:avLst/>
+          </a:prstGeom>
+          <a:noFill/>
+        </p:spPr>
+        <p:txBody>
+          <a:bodyPr wrap="square" lIns="0" rIns="0" tIns="0" bIns="0" anchor="t">
+            <a:spAutoFit/>
+          </a:bodyPr>
+          <a:lstStyle/>
+          <a:p>
+            <a:pPr algn="l">
+              <a:spcAft>
+                <a:spcPts val="0"/>
+              </a:spcAft>
+            </a:pPr>
+            <a:r>
+              <a:rPr sz="1000" b="0" i="0">
+                <a:solidFill>
+                  <a:srgbClr val="6D7B73"/>
+                </a:solidFill>
+                <a:latin typeface="Microsoft YaHei"/>
+              </a:rPr>
+              <a:t>缺训练记录/量表</a:t>
+            </a:r>
+          </a:p>
+        </p:txBody>
+      </p:sp>
+      <p:sp>
+        <p:nvSpPr>
+          <p:cNvPr id="20" name="TextBox 19"/>
+          <p:cNvSpPr txBox="1"/>
+          <p:nvPr/>
+        </p:nvSpPr>
+        <p:spPr>
+          <a:xfrm>
+            <a:off x="5596128" y="3621024"/>
+            <a:ext cx="2331720" cy="347472"/>
+          </a:xfrm>
+          <a:prstGeom prst="rect">
+            <a:avLst/>
+          </a:prstGeom>
+          <a:noFill/>
+        </p:spPr>
+        <p:txBody>
+          <a:bodyPr wrap="square" lIns="0" rIns="0" tIns="0" bIns="0" anchor="t">
+            <a:spAutoFit/>
+          </a:bodyPr>
+          <a:lstStyle/>
+          <a:p>
+            <a:pPr algn="l">
+              <a:spcAft>
+                <a:spcPts val="0"/>
+              </a:spcAft>
+            </a:pPr>
+            <a:r>
+              <a:rPr sz="1000" b="0" i="0">
+                <a:solidFill>
+                  <a:srgbClr val="6D7B73"/>
+                </a:solidFill>
+                <a:latin typeface="Microsoft YaHei"/>
+              </a:rPr>
+              <a:t>单次训练报告</a:t>
+            </a:r>
+          </a:p>
+        </p:txBody>
+      </p:sp>
+      <p:sp>
+        <p:nvSpPr>
+          <p:cNvPr id="21" name="TextBox 20"/>
+          <p:cNvSpPr txBox="1"/>
+          <p:nvPr/>
+        </p:nvSpPr>
+        <p:spPr>
+          <a:xfrm>
+            <a:off x="8065008" y="3621024"/>
+            <a:ext cx="3200400" cy="347472"/>
+          </a:xfrm>
+          <a:prstGeom prst="rect">
+            <a:avLst/>
+          </a:prstGeom>
+          <a:noFill/>
+        </p:spPr>
+        <p:txBody>
+          <a:bodyPr wrap="square" lIns="0" rIns="0" tIns="0" bIns="0" anchor="t">
+            <a:spAutoFit/>
+          </a:bodyPr>
+          <a:lstStyle/>
+          <a:p>
+            <a:pPr algn="l">
+              <a:spcAft>
+                <a:spcPts val="0"/>
+              </a:spcAft>
+            </a:pPr>
+            <a:r>
+              <a:rPr sz="1000" b="0" i="0">
+                <a:solidFill>
+                  <a:srgbClr val="6D7B73"/>
+                </a:solidFill>
+                <a:latin typeface="Microsoft YaHei"/>
+              </a:rPr>
+              <a:t>服务端记录 + 教师校准</a:t>
+            </a:r>
+          </a:p>
+        </p:txBody>
+      </p:sp>
+      <p:cxnSp>
+        <p:nvCxnSpPr>
+          <p:cNvPr id="22" name="Connector 21"/>
+          <p:cNvCxnSpPr/>
+          <p:nvPr/>
+        </p:nvCxnSpPr>
+        <p:spPr>
+          <a:xfrm>
+            <a:off x="749808" y="4059935"/>
+            <a:ext cx="10634472" cy="0"/>
+          </a:xfrm>
+          <a:prstGeom prst="line">
+            <a:avLst/>
+          </a:prstGeom>
+          <a:ln w="6985">
+            <a:solidFill>
+              <a:srgbClr val="D8D1C3"/>
+            </a:solidFill>
+          </a:ln>
+        </p:spPr>
+        <p:style>
+          <a:lnRef idx="2">
+            <a:schemeClr val="accent1"/>
+          </a:lnRef>
+          <a:fillRef idx="0">
+            <a:schemeClr val="accent1"/>
+          </a:fillRef>
+          <a:effectRef idx="1">
+            <a:schemeClr val="accent1"/>
+          </a:effectRef>
+          <a:fontRef idx="minor">
+            <a:schemeClr val="tx1"/>
+          </a:fontRef>
+        </p:style>
+      </p:cxnSp>
+      <p:sp>
+        <p:nvSpPr>
+          <p:cNvPr id="23" name="TextBox 22"/>
+          <p:cNvSpPr txBox="1"/>
+          <p:nvPr/>
+        </p:nvSpPr>
+        <p:spPr>
+          <a:xfrm>
+            <a:off x="749808" y="4242816"/>
+            <a:ext cx="2514600" cy="347472"/>
+          </a:xfrm>
+          <a:prstGeom prst="rect">
+            <a:avLst/>
+          </a:prstGeom>
+          <a:noFill/>
+        </p:spPr>
+        <p:txBody>
+          <a:bodyPr wrap="square" lIns="0" rIns="0" tIns="0" bIns="0" anchor="t">
+            <a:spAutoFit/>
+          </a:bodyPr>
+          <a:lstStyle/>
+          <a:p>
+            <a:pPr algn="l">
+              <a:spcAft>
+                <a:spcPts val="0"/>
+              </a:spcAft>
+            </a:pPr>
+            <a:r>
+              <a:rPr sz="1000" b="1" i="0">
+                <a:solidFill>
+                  <a:srgbClr val="193630"/>
+                </a:solidFill>
+                <a:latin typeface="Microsoft YaHei"/>
+              </a:rPr>
+              <a:t>正式 App</a:t>
+            </a:r>
+          </a:p>
+        </p:txBody>
+      </p:sp>
+      <p:sp>
+        <p:nvSpPr>
+          <p:cNvPr id="24" name="TextBox 23"/>
+          <p:cNvSpPr txBox="1"/>
+          <p:nvPr/>
+        </p:nvSpPr>
+        <p:spPr>
+          <a:xfrm>
+            <a:off x="3337560" y="4242816"/>
+            <a:ext cx="2148840" cy="347472"/>
+          </a:xfrm>
+          <a:prstGeom prst="rect">
+            <a:avLst/>
+          </a:prstGeom>
+          <a:noFill/>
+        </p:spPr>
+        <p:txBody>
+          <a:bodyPr wrap="square" lIns="0" rIns="0" tIns="0" bIns="0" anchor="t">
+            <a:spAutoFit/>
+          </a:bodyPr>
+          <a:lstStyle/>
+          <a:p>
+            <a:pPr algn="l">
+              <a:spcAft>
+                <a:spcPts val="0"/>
+              </a:spcAft>
+            </a:pPr>
+            <a:r>
+              <a:rPr sz="1000" b="0" i="0">
+                <a:solidFill>
+                  <a:srgbClr val="193630"/>
+                </a:solidFill>
+                <a:latin typeface="Microsoft YaHei"/>
+              </a:rPr>
+              <a:t>缺登录/接口契约</a:t>
+            </a:r>
+          </a:p>
+        </p:txBody>
+      </p:sp>
+      <p:sp>
+        <p:nvSpPr>
+          <p:cNvPr id="25" name="TextBox 24"/>
+          <p:cNvSpPr txBox="1"/>
+          <p:nvPr/>
+        </p:nvSpPr>
+        <p:spPr>
+          <a:xfrm>
+            <a:off x="5596128" y="4242816"/>
+            <a:ext cx="2331720" cy="347472"/>
+          </a:xfrm>
+          <a:prstGeom prst="rect">
+            <a:avLst/>
+          </a:prstGeom>
+          <a:noFill/>
+        </p:spPr>
+        <p:txBody>
+          <a:bodyPr wrap="square" lIns="0" rIns="0" tIns="0" bIns="0" anchor="t">
+            <a:spAutoFit/>
+          </a:bodyPr>
+          <a:lstStyle/>
+          <a:p>
+            <a:pPr algn="l">
+              <a:spcAft>
+                <a:spcPts val="0"/>
+              </a:spcAft>
+            </a:pPr>
+            <a:r>
+              <a:rPr sz="1000" b="0" i="0">
+                <a:solidFill>
+                  <a:srgbClr val="193630"/>
+                </a:solidFill>
+                <a:latin typeface="Microsoft YaHei"/>
+              </a:rPr>
+              <a:t>Web/H5 + API/SSE</a:t>
+            </a:r>
+          </a:p>
+        </p:txBody>
+      </p:sp>
+      <p:sp>
+        <p:nvSpPr>
+          <p:cNvPr id="26" name="TextBox 25"/>
+          <p:cNvSpPr txBox="1"/>
+          <p:nvPr/>
+        </p:nvSpPr>
+        <p:spPr>
+          <a:xfrm>
+            <a:off x="8065008" y="4242816"/>
+            <a:ext cx="3200400" cy="347472"/>
+          </a:xfrm>
+          <a:prstGeom prst="rect">
+            <a:avLst/>
+          </a:prstGeom>
+          <a:noFill/>
+        </p:spPr>
+        <p:txBody>
+          <a:bodyPr wrap="square" lIns="0" rIns="0" tIns="0" bIns="0" anchor="t">
+            <a:spAutoFit/>
+          </a:bodyPr>
+          <a:lstStyle/>
+          <a:p>
+            <a:pPr algn="l">
+              <a:spcAft>
+                <a:spcPts val="0"/>
+              </a:spcAft>
+            </a:pPr>
+            <a:r>
+              <a:rPr sz="1000" b="0" i="0">
+                <a:solidFill>
+                  <a:srgbClr val="193630"/>
+                </a:solidFill>
+                <a:latin typeface="Microsoft YaHei"/>
+              </a:rPr>
+              <a:t>账号、课程、消息、报告接口</a:t>
+            </a:r>
+          </a:p>
+        </p:txBody>
+      </p:sp>
+      <p:cxnSp>
+        <p:nvCxnSpPr>
+          <p:cNvPr id="27" name="Connector 26"/>
+          <p:cNvCxnSpPr/>
+          <p:nvPr/>
+        </p:nvCxnSpPr>
+        <p:spPr>
+          <a:xfrm>
+            <a:off x="749808" y="4681727"/>
+            <a:ext cx="10634472" cy="0"/>
+          </a:xfrm>
+          <a:prstGeom prst="line">
+            <a:avLst/>
+          </a:prstGeom>
+          <a:ln w="6985">
+            <a:solidFill>
+              <a:srgbClr val="D8D1C3"/>
+            </a:solidFill>
+          </a:ln>
+        </p:spPr>
+        <p:style>
+          <a:lnRef idx="2">
+            <a:schemeClr val="accent1"/>
+          </a:lnRef>
+          <a:fillRef idx="0">
+            <a:schemeClr val="accent1"/>
+          </a:fillRef>
+          <a:effectRef idx="1">
+            <a:schemeClr val="accent1"/>
+          </a:effectRef>
+          <a:fontRef idx="minor">
+            <a:schemeClr val="tx1"/>
+          </a:fontRef>
+        </p:style>
+      </p:cxnSp>
+      <p:sp>
+        <p:nvSpPr>
+          <p:cNvPr id="28" name="TextBox 27"/>
+          <p:cNvSpPr txBox="1"/>
+          <p:nvPr/>
+        </p:nvSpPr>
+        <p:spPr>
+          <a:xfrm>
+            <a:off x="749808" y="4864608"/>
+            <a:ext cx="2514600" cy="347472"/>
+          </a:xfrm>
+          <a:prstGeom prst="rect">
+            <a:avLst/>
+          </a:prstGeom>
+          <a:noFill/>
+        </p:spPr>
+        <p:txBody>
+          <a:bodyPr wrap="square" lIns="0" rIns="0" tIns="0" bIns="0" anchor="t">
+            <a:spAutoFit/>
+          </a:bodyPr>
+          <a:lstStyle/>
+          <a:p>
+            <a:pPr algn="l">
+              <a:spcAft>
+                <a:spcPts val="0"/>
+              </a:spcAft>
+            </a:pPr>
+            <a:r>
+              <a:rPr sz="1000" b="1" i="0">
+                <a:solidFill>
+                  <a:srgbClr val="6D7B73"/>
+                </a:solidFill>
+                <a:latin typeface="Microsoft YaHei"/>
+              </a:rPr>
+              <a:t>自动处方诊疗</a:t>
+            </a:r>
+          </a:p>
+        </p:txBody>
+      </p:sp>
+      <p:sp>
+        <p:nvSpPr>
+          <p:cNvPr id="29" name="TextBox 28"/>
+          <p:cNvSpPr txBox="1"/>
+          <p:nvPr/>
+        </p:nvSpPr>
+        <p:spPr>
+          <a:xfrm>
+            <a:off x="3337560" y="4864608"/>
+            <a:ext cx="2148840" cy="347472"/>
+          </a:xfrm>
+          <a:prstGeom prst="rect">
+            <a:avLst/>
+          </a:prstGeom>
+          <a:noFill/>
+        </p:spPr>
+        <p:txBody>
+          <a:bodyPr wrap="square" lIns="0" rIns="0" tIns="0" bIns="0" anchor="t">
+            <a:spAutoFit/>
+          </a:bodyPr>
+          <a:lstStyle/>
+          <a:p>
+            <a:pPr algn="l">
+              <a:spcAft>
+                <a:spcPts val="0"/>
+              </a:spcAft>
+            </a:pPr>
+            <a:r>
+              <a:rPr sz="1000" b="0" i="0">
+                <a:solidFill>
+                  <a:srgbClr val="6D7B73"/>
+                </a:solidFill>
+                <a:latin typeface="Microsoft YaHei"/>
+              </a:rPr>
+              <a:t>安全与合规边界</a:t>
+            </a:r>
+          </a:p>
+        </p:txBody>
+      </p:sp>
+      <p:sp>
+        <p:nvSpPr>
+          <p:cNvPr id="30" name="TextBox 29"/>
+          <p:cNvSpPr txBox="1"/>
+          <p:nvPr/>
+        </p:nvSpPr>
+        <p:spPr>
+          <a:xfrm>
+            <a:off x="5596128" y="4864608"/>
+            <a:ext cx="2331720" cy="347472"/>
+          </a:xfrm>
+          <a:prstGeom prst="rect">
+            <a:avLst/>
+          </a:prstGeom>
+          <a:noFill/>
+        </p:spPr>
+        <p:txBody>
+          <a:bodyPr wrap="square" lIns="0" rIns="0" tIns="0" bIns="0" anchor="t">
+            <a:spAutoFit/>
+          </a:bodyPr>
+          <a:lstStyle/>
+          <a:p>
+            <a:pPr algn="l">
+              <a:spcAft>
+                <a:spcPts val="0"/>
+              </a:spcAft>
+            </a:pPr>
+            <a:r>
+              <a:rPr sz="1000" b="0" i="0">
+                <a:solidFill>
+                  <a:srgbClr val="6D7B73"/>
+                </a:solidFill>
+                <a:latin typeface="Microsoft YaHei"/>
+              </a:rPr>
+              <a:t>安全闸 + 人工审核</a:t>
+            </a:r>
+          </a:p>
+        </p:txBody>
+      </p:sp>
+      <p:sp>
+        <p:nvSpPr>
+          <p:cNvPr id="31" name="TextBox 30"/>
+          <p:cNvSpPr txBox="1"/>
+          <p:nvPr/>
+        </p:nvSpPr>
+        <p:spPr>
+          <a:xfrm>
+            <a:off x="8065008" y="4864608"/>
+            <a:ext cx="3200400" cy="347472"/>
+          </a:xfrm>
+          <a:prstGeom prst="rect">
+            <a:avLst/>
+          </a:prstGeom>
+          <a:noFill/>
+        </p:spPr>
+        <p:txBody>
+          <a:bodyPr wrap="square" lIns="0" rIns="0" tIns="0" bIns="0" anchor="t">
+            <a:spAutoFit/>
+          </a:bodyPr>
+          <a:lstStyle/>
+          <a:p>
+            <a:pPr algn="l">
+              <a:spcAft>
+                <a:spcPts val="0"/>
+              </a:spcAft>
+            </a:pPr>
+            <a:r>
+              <a:rPr sz="1000" b="0" i="0">
+                <a:solidFill>
+                  <a:srgbClr val="6D7B73"/>
+                </a:solidFill>
+                <a:latin typeface="Microsoft YaHei"/>
+              </a:rPr>
+              <a:t>教学解释与医师审核流程</a:t>
+            </a:r>
+          </a:p>
+        </p:txBody>
+      </p:sp>
+      <p:cxnSp>
+        <p:nvCxnSpPr>
+          <p:cNvPr id="32" name="Connector 31"/>
+          <p:cNvCxnSpPr/>
+          <p:nvPr/>
+        </p:nvCxnSpPr>
+        <p:spPr>
+          <a:xfrm>
+            <a:off x="749808" y="5303520"/>
+            <a:ext cx="10634472" cy="0"/>
+          </a:xfrm>
+          <a:prstGeom prst="line">
+            <a:avLst/>
+          </a:prstGeom>
+          <a:ln w="6985">
+            <a:solidFill>
+              <a:srgbClr val="D8D1C3"/>
+            </a:solidFill>
+          </a:ln>
+        </p:spPr>
+        <p:style>
+          <a:lnRef idx="2">
+            <a:schemeClr val="accent1"/>
+          </a:lnRef>
+          <a:fillRef idx="0">
+            <a:schemeClr val="accent1"/>
+          </a:fillRef>
+          <a:effectRef idx="1">
+            <a:schemeClr val="accent1"/>
+          </a:effectRef>
+          <a:fontRef idx="minor">
+            <a:schemeClr val="tx1"/>
+          </a:fontRef>
+        </p:style>
+      </p:cxnSp>
+      <p:sp>
+        <p:nvSpPr>
+          <p:cNvPr id="33" name="TextBox 32"/>
+          <p:cNvSpPr txBox="1"/>
+          <p:nvPr/>
+        </p:nvSpPr>
+        <p:spPr>
+          <a:xfrm>
+            <a:off x="768096" y="5669280"/>
+            <a:ext cx="10469880" cy="256032"/>
+          </a:xfrm>
+          <a:prstGeom prst="rect">
+            <a:avLst/>
+          </a:prstGeom>
+          <a:noFill/>
+        </p:spPr>
+        <p:txBody>
+          <a:bodyPr wrap="square" lIns="0" rIns="0" tIns="0" bIns="0" anchor="t">
+            <a:spAutoFit/>
+          </a:bodyPr>
+          <a:lstStyle/>
+          <a:p>
+            <a:pPr algn="l">
+              <a:spcAft>
+                <a:spcPts val="0"/>
+              </a:spcAft>
+            </a:pPr>
+            <a:r>
+              <a:rPr sz="1100" b="1" i="0">
+                <a:solidFill>
+                  <a:srgbClr val="C85D48"/>
+                </a:solidFill>
+                <a:latin typeface="Microsoft YaHei"/>
+              </a:rPr>
+              <a:t>原则：缺真实资料就先做授权演示；缺历史数据就先做单次报告；缺接口就先验证 Web 闭环；高风险内容始终人工优先。</a:t>
+            </a:r>
+          </a:p>
+        </p:txBody>
+      </p:sp>
+    </p:spTree>
+  </p:cSld>
+  <p:clrMapOvr>
+    <a:masterClrMapping/>
+  </p:clrMapOvr>
+</p:sld>
+</file>
+
+<file path=ppt/slides/slide13.xml><?xml version="1.0" encoding="utf-8"?>
+<p:sld xmlns:a="http://schemas.openxmlformats.org/drawingml/2006/main" xmlns:p="http://schemas.openxmlformats.org/presentationml/2006/main" xmlns:r="http://schemas.openxmlformats.org/officeDocument/2006/relationships">
+  <p:cSld>
+    <p:bg>
+      <p:bgPr>
+        <a:solidFill>
+          <a:srgbClr val="103A32"/>
+        </a:solidFill>
+        <a:effectLst/>
+      </p:bgPr>
+    </p:bg>
+    <p:spTree>
+      <p:nvGrpSpPr>
+        <p:cNvPr id="1" name=""/>
+        <p:cNvGrpSpPr/>
+        <p:nvPr/>
+      </p:nvGrpSpPr>
+      <p:grpSpPr/>
+      <p:sp>
+        <p:nvSpPr>
+          <p:cNvPr id="2" name="TextBox 1"/>
+          <p:cNvSpPr txBox="1"/>
+          <p:nvPr/>
+        </p:nvSpPr>
+        <p:spPr>
+          <a:xfrm>
+            <a:off x="502920" y="292608"/>
+            <a:ext cx="5029200" cy="182880"/>
+          </a:xfrm>
+          <a:prstGeom prst="rect">
+            <a:avLst/>
+          </a:prstGeom>
+          <a:noFill/>
+        </p:spPr>
+        <p:txBody>
+          <a:bodyPr wrap="square" lIns="0" rIns="0" tIns="0" bIns="0" anchor="t">
+            <a:spAutoFit/>
+          </a:bodyPr>
+          <a:lstStyle/>
+          <a:p>
+            <a:pPr algn="l">
+              <a:spcAft>
+                <a:spcPts val="0"/>
+              </a:spcAft>
+            </a:pPr>
+            <a:r>
+              <a:rPr sz="800" b="1" i="0">
+                <a:solidFill>
+                  <a:srgbClr val="D7C58F"/>
+                </a:solidFill>
+                <a:latin typeface="Microsoft YaHei"/>
+              </a:rPr>
+              <a:t>华医世界 · 中医课程 AI 产品方案</a:t>
+            </a:r>
+          </a:p>
+        </p:txBody>
+      </p:sp>
+      <p:sp>
+        <p:nvSpPr>
+          <p:cNvPr id="3" name="TextBox 2"/>
+          <p:cNvSpPr txBox="1"/>
+          <p:nvPr/>
+        </p:nvSpPr>
+        <p:spPr>
+          <a:xfrm>
+            <a:off x="11201400" y="292608"/>
+            <a:ext cx="502920" cy="182880"/>
+          </a:xfrm>
+          <a:prstGeom prst="rect">
+            <a:avLst/>
+          </a:prstGeom>
+          <a:noFill/>
+        </p:spPr>
+        <p:txBody>
+          <a:bodyPr wrap="square" lIns="0" rIns="0" tIns="0" bIns="0" anchor="t">
+            <a:spAutoFit/>
+          </a:bodyPr>
+          <a:lstStyle/>
+          <a:p>
+            <a:pPr algn="r">
+              <a:spcAft>
+                <a:spcPts val="0"/>
+              </a:spcAft>
+            </a:pPr>
+            <a:r>
+              <a:rPr sz="800" b="1" i="0">
+                <a:solidFill>
+                  <a:srgbClr val="D7C58F"/>
+                </a:solidFill>
+                <a:latin typeface="Microsoft YaHei"/>
+              </a:rPr>
+              <a:t>13</a:t>
+            </a:r>
+          </a:p>
+        </p:txBody>
+      </p:sp>
+      <p:sp>
+        <p:nvSpPr>
+          <p:cNvPr id="4" name="TextBox 3"/>
+          <p:cNvSpPr txBox="1"/>
+          <p:nvPr/>
+        </p:nvSpPr>
+        <p:spPr>
+          <a:xfrm>
+            <a:off x="502920" y="6382512"/>
+            <a:ext cx="5486400" cy="182880"/>
+          </a:xfrm>
+          <a:prstGeom prst="rect">
+            <a:avLst/>
+          </a:prstGeom>
+          <a:noFill/>
+        </p:spPr>
+        <p:txBody>
+          <a:bodyPr wrap="square" lIns="0" rIns="0" tIns="0" bIns="0" anchor="t">
+            <a:spAutoFit/>
+          </a:bodyPr>
+          <a:lstStyle/>
+          <a:p>
+            <a:pPr algn="l">
+              <a:spcAft>
+                <a:spcPts val="0"/>
+              </a:spcAft>
+            </a:pPr>
+            <a:r>
+              <a:rPr sz="800" b="1" i="0">
+                <a:solidFill>
+                  <a:srgbClr val="D7C58F"/>
+                </a:solidFill>
+                <a:latin typeface="Microsoft YaHei"/>
+              </a:rPr>
+              <a:t>12 · 岗位边界</a:t>
+            </a:r>
+          </a:p>
+        </p:txBody>
+      </p:sp>
+      <p:cxnSp>
+        <p:nvCxnSpPr>
+          <p:cNvPr id="5" name="Connector 4"/>
+          <p:cNvCxnSpPr/>
+          <p:nvPr/>
+        </p:nvCxnSpPr>
+        <p:spPr>
+          <a:xfrm>
+            <a:off x="502920" y="6245352"/>
+            <a:ext cx="11183112" cy="0"/>
+          </a:xfrm>
+          <a:prstGeom prst="line">
+            <a:avLst/>
+          </a:prstGeom>
+          <a:ln w="8890">
+            <a:solidFill>
+              <a:srgbClr val="4C6C61"/>
+            </a:solidFill>
+          </a:ln>
+        </p:spPr>
+        <p:style>
+          <a:lnRef idx="2">
+            <a:schemeClr val="accent1"/>
+          </a:lnRef>
+          <a:fillRef idx="0">
+            <a:schemeClr val="accent1"/>
+          </a:fillRef>
+          <a:effectRef idx="1">
+            <a:schemeClr val="accent1"/>
+          </a:effectRef>
+          <a:fontRef idx="minor">
+            <a:schemeClr val="tx1"/>
+          </a:fontRef>
+        </p:style>
+      </p:cxnSp>
+      <p:sp>
+        <p:nvSpPr>
+          <p:cNvPr id="6" name="TextBox 5"/>
+          <p:cNvSpPr txBox="1"/>
+          <p:nvPr/>
+        </p:nvSpPr>
+        <p:spPr>
+          <a:xfrm>
+            <a:off x="685800" y="868680"/>
+            <a:ext cx="7498079" cy="960120"/>
+          </a:xfrm>
+          <a:prstGeom prst="rect">
+            <a:avLst/>
+          </a:prstGeom>
+          <a:noFill/>
+        </p:spPr>
+        <p:txBody>
+          <a:bodyPr wrap="square" lIns="0" rIns="0" tIns="0" bIns="0" anchor="t">
+            <a:spAutoFit/>
+          </a:bodyPr>
+          <a:lstStyle/>
+          <a:p>
+            <a:pPr algn="l">
+              <a:spcAft>
+                <a:spcPts val="0"/>
+              </a:spcAft>
+            </a:pPr>
+            <a:r>
+              <a:rPr sz="2800" b="1" i="0">
+                <a:solidFill>
+                  <a:srgbClr val="FFFDF8"/>
+                </a:solidFill>
+                <a:latin typeface="Microsoft YaHei"/>
+              </a:rPr>
+              <a:t>我可以承担 0→1，但不会盲目承诺单人包办。</a:t>
+            </a:r>
+          </a:p>
+        </p:txBody>
+      </p:sp>
+      <p:sp>
+        <p:nvSpPr>
+          <p:cNvPr id="7" name="TextBox 6"/>
+          <p:cNvSpPr txBox="1"/>
+          <p:nvPr/>
+        </p:nvSpPr>
+        <p:spPr>
+          <a:xfrm>
+            <a:off x="704088" y="1883664"/>
+            <a:ext cx="7955279" cy="548640"/>
+          </a:xfrm>
+          <a:prstGeom prst="rect">
+            <a:avLst/>
+          </a:prstGeom>
+          <a:noFill/>
+        </p:spPr>
+        <p:txBody>
+          <a:bodyPr wrap="square" lIns="0" rIns="0" tIns="0" bIns="0" anchor="t">
+            <a:spAutoFit/>
+          </a:bodyPr>
+          <a:lstStyle/>
+          <a:p>
+            <a:pPr algn="l">
+              <a:spcAft>
+                <a:spcPts val="0"/>
+              </a:spcAft>
+            </a:pPr>
+            <a:r>
+              <a:rPr sz="1200" b="0" i="0">
+                <a:solidFill>
+                  <a:srgbClr val="C7D6CC"/>
+                </a:solidFill>
+                <a:latin typeface="Microsoft YaHei"/>
+              </a:rPr>
+              <a:t>先对结果负责，再把需要协作的边界讲清楚，反而更适合早期项目。</a:t>
+            </a:r>
+          </a:p>
+        </p:txBody>
+      </p:sp>
+      <p:sp>
+        <p:nvSpPr>
+          <p:cNvPr id="8" name="Rounded Rectangle 7"/>
+          <p:cNvSpPr/>
+          <p:nvPr/>
+        </p:nvSpPr>
+        <p:spPr>
+          <a:xfrm>
+            <a:off x="749808" y="2743200"/>
+            <a:ext cx="5166360" cy="2423160"/>
+          </a:xfrm>
+          <a:prstGeom prst="roundRect">
+            <a:avLst/>
+          </a:prstGeom>
+          <a:solidFill>
+            <a:srgbClr val="1E5A4A"/>
+          </a:solidFill>
+          <a:ln w="10160">
+            <a:solidFill>
+              <a:srgbClr val="477A69"/>
+            </a:solidFill>
+          </a:ln>
+        </p:spPr>
+        <p:style>
+          <a:lnRef idx="1">
+            <a:schemeClr val="accent1"/>
+          </a:lnRef>
+          <a:fillRef idx="3">
+            <a:schemeClr val="accent1"/>
+          </a:fillRef>
+          <a:effectRef idx="2">
+            <a:schemeClr val="accent1"/>
+          </a:effectRef>
+          <a:fontRef idx="minor">
+            <a:schemeClr val="lt1"/>
+          </a:fontRef>
+        </p:style>
+        <p:txBody>
+          <a:bodyPr rtlCol="0" anchor="ctr"/>
+          <a:lstStyle/>
+          <a:p>
+            <a:pPr algn="ctr"/>
+          </a:p>
+        </p:txBody>
+      </p:sp>
+      <p:sp>
+        <p:nvSpPr>
+          <p:cNvPr id="9" name="TextBox 8"/>
+          <p:cNvSpPr txBox="1"/>
+          <p:nvPr/>
+        </p:nvSpPr>
+        <p:spPr>
+          <a:xfrm>
+            <a:off x="1024128" y="3063240"/>
+            <a:ext cx="2377440" cy="274320"/>
+          </a:xfrm>
+          <a:prstGeom prst="rect">
+            <a:avLst/>
+          </a:prstGeom>
+          <a:noFill/>
+        </p:spPr>
+        <p:txBody>
+          <a:bodyPr wrap="square" lIns="0" rIns="0" tIns="0" bIns="0" anchor="t">
+            <a:spAutoFit/>
+          </a:bodyPr>
+          <a:lstStyle/>
+          <a:p>
+            <a:pPr algn="l">
+              <a:spcAft>
+                <a:spcPts val="0"/>
+              </a:spcAft>
+            </a:pPr>
+            <a:r>
+              <a:rPr sz="1800" b="1" i="0">
+                <a:solidFill>
+                  <a:srgbClr val="D7C58F"/>
+                </a:solidFill>
+                <a:latin typeface="Microsoft YaHei"/>
+              </a:rPr>
+              <a:t>我可以独立负责</a:t>
+            </a:r>
+          </a:p>
+        </p:txBody>
+      </p:sp>
+      <p:sp>
+        <p:nvSpPr>
+          <p:cNvPr id="10" name="TextBox 9"/>
+          <p:cNvSpPr txBox="1"/>
+          <p:nvPr/>
+        </p:nvSpPr>
+        <p:spPr>
+          <a:xfrm>
+            <a:off x="1024128" y="3584448"/>
+            <a:ext cx="4297680" cy="1143000"/>
+          </a:xfrm>
+          <a:prstGeom prst="rect">
+            <a:avLst/>
+          </a:prstGeom>
+          <a:noFill/>
+        </p:spPr>
+        <p:txBody>
+          <a:bodyPr wrap="square" lIns="0" rIns="0" tIns="0" bIns="0" anchor="t">
+            <a:spAutoFit/>
+          </a:bodyPr>
+          <a:lstStyle/>
+          <a:p>
+            <a:pPr algn="l">
+              <a:spcAft>
+                <a:spcPts val="0"/>
+              </a:spcAft>
+            </a:pPr>
+            <a:r>
+              <a:rPr sz="1200" b="0" i="0">
+                <a:solidFill>
+                  <a:srgbClr val="FFFDF8"/>
+                </a:solidFill>
+                <a:latin typeface="Microsoft YaHei"/>
+              </a:rPr>
+              <a:t>场景调研与 MVP 定义
+AI 应用层：RAG、Agent、提示词、接口
+前端原型、流式体验、部署与 Trace
+评测集、Bad Case 和迭代文档</a:t>
+            </a:r>
+          </a:p>
+        </p:txBody>
+      </p:sp>
+      <p:sp>
+        <p:nvSpPr>
+          <p:cNvPr id="11" name="Rounded Rectangle 10"/>
+          <p:cNvSpPr/>
+          <p:nvPr/>
+        </p:nvSpPr>
+        <p:spPr>
+          <a:xfrm>
+            <a:off x="6245352" y="2743200"/>
+            <a:ext cx="5166360" cy="2423160"/>
+          </a:xfrm>
+          <a:prstGeom prst="roundRect">
+            <a:avLst/>
+          </a:prstGeom>
+          <a:solidFill>
+            <a:srgbClr val="174A40"/>
+          </a:solidFill>
+          <a:ln w="10160">
+            <a:solidFill>
+              <a:srgbClr val="477A69"/>
+            </a:solidFill>
+          </a:ln>
+        </p:spPr>
+        <p:style>
+          <a:lnRef idx="1">
+            <a:schemeClr val="accent1"/>
+          </a:lnRef>
+          <a:fillRef idx="3">
+            <a:schemeClr val="accent1"/>
+          </a:fillRef>
+          <a:effectRef idx="2">
+            <a:schemeClr val="accent1"/>
+          </a:effectRef>
+          <a:fontRef idx="minor">
+            <a:schemeClr val="lt1"/>
+          </a:fontRef>
+        </p:style>
+        <p:txBody>
+          <a:bodyPr rtlCol="0" anchor="ctr"/>
+          <a:lstStyle/>
+          <a:p>
+            <a:pPr algn="ctr"/>
+          </a:p>
+        </p:txBody>
+      </p:sp>
+      <p:sp>
+        <p:nvSpPr>
+          <p:cNvPr id="12" name="TextBox 11"/>
+          <p:cNvSpPr txBox="1"/>
+          <p:nvPr/>
+        </p:nvSpPr>
+        <p:spPr>
+          <a:xfrm>
+            <a:off x="6519672" y="3063240"/>
+            <a:ext cx="2560320" cy="274320"/>
+          </a:xfrm>
+          <a:prstGeom prst="rect">
+            <a:avLst/>
+          </a:prstGeom>
+          <a:noFill/>
+        </p:spPr>
+        <p:txBody>
+          <a:bodyPr wrap="square" lIns="0" rIns="0" tIns="0" bIns="0" anchor="t">
+            <a:spAutoFit/>
+          </a:bodyPr>
+          <a:lstStyle/>
+          <a:p>
+            <a:pPr algn="l">
+              <a:spcAft>
+                <a:spcPts val="0"/>
+              </a:spcAft>
+            </a:pPr>
+            <a:r>
+              <a:rPr sz="1800" b="1" i="0">
+                <a:solidFill>
+                  <a:srgbClr val="D7C58F"/>
+                </a:solidFill>
+                <a:latin typeface="Microsoft YaHei"/>
+              </a:rPr>
+              <a:t>正式上线需要协作</a:t>
+            </a:r>
+          </a:p>
+        </p:txBody>
+      </p:sp>
+      <p:sp>
+        <p:nvSpPr>
+          <p:cNvPr id="13" name="TextBox 12"/>
+          <p:cNvSpPr txBox="1"/>
+          <p:nvPr/>
+        </p:nvSpPr>
+        <p:spPr>
+          <a:xfrm>
+            <a:off x="6519672" y="3584448"/>
+            <a:ext cx="4297680" cy="1143000"/>
+          </a:xfrm>
+          <a:prstGeom prst="rect">
+            <a:avLst/>
+          </a:prstGeom>
+          <a:noFill/>
+        </p:spPr>
+        <p:txBody>
+          <a:bodyPr wrap="square" lIns="0" rIns="0" tIns="0" bIns="0" anchor="t">
+            <a:spAutoFit/>
+          </a:bodyPr>
+          <a:lstStyle/>
+          <a:p>
+            <a:pPr algn="l">
+              <a:spcAft>
+                <a:spcPts val="0"/>
+              </a:spcAft>
+            </a:pPr>
+            <a:r>
+              <a:rPr sz="1200" b="0" i="0">
+                <a:solidFill>
+                  <a:srgbClr val="C7D6CC"/>
+                </a:solidFill>
+                <a:latin typeface="Microsoft YaHei"/>
+              </a:rPr>
+              <a:t>App 正式接入与账号体系
+数据治理、运维、成本与安全
+中医教师审核与课程版权
+规模化并发和产品运营</a:t>
+            </a:r>
+          </a:p>
+        </p:txBody>
+      </p:sp>
+      <p:sp>
+        <p:nvSpPr>
+          <p:cNvPr id="14" name="TextBox 13"/>
+          <p:cNvSpPr txBox="1"/>
+          <p:nvPr/>
+        </p:nvSpPr>
+        <p:spPr>
+          <a:xfrm>
+            <a:off x="804672" y="5577840"/>
+            <a:ext cx="10469880" cy="274320"/>
+          </a:xfrm>
+          <a:prstGeom prst="rect">
+            <a:avLst/>
+          </a:prstGeom>
+          <a:noFill/>
+        </p:spPr>
+        <p:txBody>
+          <a:bodyPr wrap="square" lIns="0" rIns="0" tIns="0" bIns="0" anchor="t">
+            <a:spAutoFit/>
+          </a:bodyPr>
+          <a:lstStyle/>
+          <a:p>
+            <a:pPr algn="l">
+              <a:spcAft>
+                <a:spcPts val="0"/>
+              </a:spcAft>
+            </a:pPr>
+            <a:r>
+              <a:rPr sz="1200" b="1" i="0">
+                <a:solidFill>
+                  <a:srgbClr val="D7C58F"/>
+                </a:solidFill>
+                <a:latin typeface="Microsoft YaHei"/>
+              </a:rPr>
+              <a:t>岗位沟通：如果职责是 AI 方向从 0 到 1，我期望转正 25K 左右；具体可结合首期目标、资源和绩效机制沟通。</a:t>
+            </a:r>
+          </a:p>
+        </p:txBody>
+      </p:sp>
+    </p:spTree>
+  </p:cSld>
+  <p:clrMapOvr>
+    <a:masterClrMapping/>
+  </p:clrMapOvr>
+</p:sld>
+</file>
+
+<file path=ppt/slides/slide14.xml><?xml version="1.0" encoding="utf-8"?>
+<p:sld xmlns:a="http://schemas.openxmlformats.org/drawingml/2006/main" xmlns:p="http://schemas.openxmlformats.org/presentationml/2006/main" xmlns:r="http://schemas.openxmlformats.org/officeDocument/2006/relationships">
+  <p:cSld>
+    <p:bg>
+      <p:bgPr>
+        <a:solidFill>
+          <a:srgbClr val="F7F1E4"/>
+        </a:solidFill>
+        <a:effectLst/>
+      </p:bgPr>
+    </p:bg>
+    <p:spTree>
+      <p:nvGrpSpPr>
+        <p:cNvPr id="1" name=""/>
+        <p:cNvGrpSpPr/>
+        <p:nvPr/>
+      </p:nvGrpSpPr>
+      <p:grpSpPr/>
+      <p:sp>
+        <p:nvSpPr>
+          <p:cNvPr id="2" name="TextBox 1"/>
+          <p:cNvSpPr txBox="1"/>
+          <p:nvPr/>
+        </p:nvSpPr>
+        <p:spPr>
+          <a:xfrm>
+            <a:off x="502920" y="292608"/>
+            <a:ext cx="5029200" cy="182880"/>
+          </a:xfrm>
+          <a:prstGeom prst="rect">
+            <a:avLst/>
+          </a:prstGeom>
+          <a:noFill/>
+        </p:spPr>
+        <p:txBody>
+          <a:bodyPr wrap="square" lIns="0" rIns="0" tIns="0" bIns="0" anchor="t">
+            <a:spAutoFit/>
+          </a:bodyPr>
+          <a:lstStyle/>
+          <a:p>
+            <a:pPr algn="l">
+              <a:spcAft>
+                <a:spcPts val="0"/>
+              </a:spcAft>
+            </a:pPr>
+            <a:r>
+              <a:rPr sz="800" b="1" i="0">
+                <a:solidFill>
+                  <a:srgbClr val="C85D48"/>
+                </a:solidFill>
+                <a:latin typeface="Microsoft YaHei"/>
+              </a:rPr>
+              <a:t>华医世界 · 中医课程 AI 产品方案</a:t>
+            </a:r>
+          </a:p>
+        </p:txBody>
+      </p:sp>
+      <p:sp>
+        <p:nvSpPr>
+          <p:cNvPr id="3" name="TextBox 2"/>
+          <p:cNvSpPr txBox="1"/>
+          <p:nvPr/>
+        </p:nvSpPr>
+        <p:spPr>
+          <a:xfrm>
+            <a:off x="11201400" y="292608"/>
+            <a:ext cx="502920" cy="182880"/>
+          </a:xfrm>
+          <a:prstGeom prst="rect">
+            <a:avLst/>
+          </a:prstGeom>
+          <a:noFill/>
+        </p:spPr>
+        <p:txBody>
+          <a:bodyPr wrap="square" lIns="0" rIns="0" tIns="0" bIns="0" anchor="t">
+            <a:spAutoFit/>
+          </a:bodyPr>
+          <a:lstStyle/>
+          <a:p>
+            <a:pPr algn="r">
+              <a:spcAft>
+                <a:spcPts val="0"/>
+              </a:spcAft>
+            </a:pPr>
+            <a:r>
+              <a:rPr sz="800" b="1" i="0">
+                <a:solidFill>
+                  <a:srgbClr val="6D7B73"/>
+                </a:solidFill>
+                <a:latin typeface="Microsoft YaHei"/>
+              </a:rPr>
+              <a:t>14</a:t>
+            </a:r>
+          </a:p>
+        </p:txBody>
+      </p:sp>
+      <p:sp>
+        <p:nvSpPr>
+          <p:cNvPr id="4" name="TextBox 3"/>
+          <p:cNvSpPr txBox="1"/>
+          <p:nvPr/>
+        </p:nvSpPr>
+        <p:spPr>
+          <a:xfrm>
+            <a:off x="502920" y="6382512"/>
+            <a:ext cx="5486400" cy="182880"/>
+          </a:xfrm>
+          <a:prstGeom prst="rect">
+            <a:avLst/>
+          </a:prstGeom>
+          <a:noFill/>
+        </p:spPr>
+        <p:txBody>
+          <a:bodyPr wrap="square" lIns="0" rIns="0" tIns="0" bIns="0" anchor="t">
+            <a:spAutoFit/>
+          </a:bodyPr>
+          <a:lstStyle/>
+          <a:p>
+            <a:pPr algn="l">
+              <a:spcAft>
+                <a:spcPts val="0"/>
+              </a:spcAft>
+            </a:pPr>
+            <a:r>
+              <a:rPr sz="800" b="1" i="0">
+                <a:solidFill>
+                  <a:srgbClr val="6D7B73"/>
+                </a:solidFill>
+                <a:latin typeface="Microsoft YaHei"/>
+              </a:rPr>
+              <a:t>13 · 结论</a:t>
             </a:r>
           </a:p>
         </p:txBody>

</xml_diff>